<commit_message>
feat(inbox/aan): deck follow-ups for the SSA review response
Closes the doc-to-deck loop from commit 0637be27:
- roadmap deck: two new slides — 'Mechanism, not product' (6-layer
  condensed alternatives table + leadership doctrine banner) and 'The
  governance & ownership model' (matrix / D1-D14 register / go-no-go
  cards + the D0 ratification ask). 8 -> 10 slides, Date Code 15:28 ET
- Book 00 deck: Closure Necessity Doctrine slide notes gain the
  mechanism-not-product standing correction (mirrors the Book 00
  callout); Date Code 15:28 ET across all 22 slides

Zip rebuilt as AAN_Federal_Series_Complete_2026-07-07_1529ET.zip
(29 entries); OneDrive reconciled 31/31 hash-verified.

Co-Authored-By: Claude Fable 5 <noreply@anthropic.com>
</commit_message>
<xml_diff>
--- a/inbox/Application Aware Networking/Book_00_FedAAN_Executive_Summary.pptx
+++ b/inbox/Application Aware Networking/Book_00_FedAAN_Executive_Summary.pptx
@@ -2354,19 +2354,43 @@
           <a:lstStyle/>
           <a:p>
             <a:r>
-              <a:rPr lang="en-US" dirty="0"/>
-              <a:t>THE CLOSURE NECESSITY DOCTRINE — the claim is stronger than "recommended" and it is falsifiable: for a specific, enumerable set of NIST SP 800-53 Rev 5 controls, three technologies are the ONLY closure mechanisms. Every "required" in the series pairs with the control text, physics, or protocol behavior that makes the alternatives impossible — never with an adjective.
-1. IPAM/DDI (authoritative naming-and-addressing plane). Controls with no alternate closure path: SC-20, SC-20(1), SC-21, SC-22 (authoritative/recursive DNS); CM-8, CM-8(1) (component inventory); IA-9 (service identification). Why: you cannot attest authoritative name resolution without an authoritative resolver, and you cannot inventory what you cannot enumerate. No scanner creates a source of truth — a scanner can only measure drift from one.
-2. SD-WAN (encrypted, application-aware transport overlay). Controls: SC-8, SC-8(1) on DIA circuits (network-layer encryption); SC-5 (traffic-class separation); SI-4 (application-layer telemetry on transport). Why: a pipe has no encryption, no path intelligence, and no telemetry. Physics gives DIA lower latency; only the overlay gives it a control surface. There is no second way to encrypt a DIA circuit at the network layer.
-3. TIC 3.0 (distributed policy enforcement for the pipes). Controls: SC-7, SC-7(7) (boundary protection on distributed egress); AC-4 (information flow enforcement outside the legacy TIC access point). Why: under TIC 3.0, DIA is permissible ONLY WHEN the security-capabilities catalog is satisfied at the distributed enforcement point — the SASE stack. An ungoverned DIA circuit is not a modernization; it is a finding.
-BASELINE CAVEAT: these closure claims are made against the NIST SP 800-53 Rev 5 baseline and FedRAMP 20x CR26 rules effective June 25, 2026. Changes to the baseline, new FedRAMP-authorized product entries, or revised assessment guidance may alter these closure paths. Validate with OIS and the agency's 3PAO before using these claims as the basis for authorization decisions.
-The KSI Closure Necessity Matrix (slide 10) quantifies this doctrine against all 29 FedRAMP 20x KSI rules.</a:t>
-            </a:r>
-            <a:endParaRPr lang="en-US" dirty="0"/>
+              <a:t>THE CLOSURE NECESSITY DOCTRINE — the claim is stronger than "recommended" and it is falsifiable: for a specific, enumerable set of NIST SP 800-53 Rev 5 controls, three technologies are the ONLY closure mechanisms. Every "required" in the series pairs with the control text, physics, or protocol behavior that makes the alternatives impossible — never with an adjective.</a:t>
+            </a:r>
+          </a:p>
+          <a:p>
+            <a:r>
+              <a:t>1. IPAM/DDI (authoritative naming-and-addressing plane). Controls with no alternate closure path: SC-20, SC-20(1), SC-21, SC-22 (authoritative/recursive DNS); CM-8, CM-8(1) (component inventory); IA-9 (service identification). Why: you cannot attest authoritative name resolution without an authoritative resolver, and you cannot inventory what you cannot enumerate. No scanner creates a source of truth — a scanner can only measure drift from one.</a:t>
+            </a:r>
+          </a:p>
+          <a:p>
+            <a:r>
+              <a:t>2. SD-WAN (encrypted, application-aware transport overlay). Controls: SC-8, SC-8(1) on DIA circuits (network-layer encryption); SC-5 (traffic-class separation); SI-4 (application-layer telemetry on transport). Why: a pipe has no encryption, no path intelligence, and no telemetry. Physics gives DIA lower latency; only the overlay gives it a control surface. There is no second way to encrypt a DIA circuit at the network layer.</a:t>
+            </a:r>
+          </a:p>
+          <a:p>
+            <a:r>
+              <a:t>3. TIC 3.0 (distributed policy enforcement for the pipes). Controls: SC-7, SC-7(7) (boundary protection on distributed egress); AC-4 (information flow enforcement outside the legacy TIC access point). Why: under TIC 3.0, DIA is permissible ONLY WHEN the security-capabilities catalog is satisfied at the distributed enforcement point — the SASE stack. An ungoverned DIA circuit is not a modernization; it is a finding.</a:t>
+            </a:r>
+          </a:p>
+          <a:p>
+            <a:r>
+              <a:t>BASELINE CAVEAT: these closure claims are made against the NIST SP 800-53 Rev 5 baseline and FedRAMP 20x CR26 rules effective June 25, 2026. Changes to the baseline, new FedRAMP-authorized product entries, or revised assessment guidance may alter these closure paths. Validate with OIS and the agency's 3PAO before using these claims as the basis for authorization decisions.</a:t>
+            </a:r>
+          </a:p>
+          <a:p>
+            <a:r>
+              <a:t>The KSI Closure Necessity Matrix (slide 10) quantifies this doctrine against all 29 FedRAMP 20x KSI rules.</a:t>
+            </a:r>
           </a:p>
           <a:p>
             <a:r>
               <a:t>Vendor sources: https://csrc.nist.gov/pubs/sp/800/53/r5/upd1/final | uiao repo: inbox/Application Aware Networking/Book_00_FedAAN_Executive_Summary.qmd</a:t>
+            </a:r>
+          </a:p>
+          <a:p/>
+          <a:p>
+            <a:r>
+              <a:t>MECHANISM, NOT PRODUCT (added 2026-07-07, SSA review response — mirrors the new Book 00 callout): 'no alternate closure path' is a claim about mechanism classes, never vendors. Every product named in the series is a deployed example of its mechanism, and FedRAMP-authorized alternatives exist at every layer — the alternatives matrix in the ConMon Gap Roadmap enumerates them (DDI, NAC/RADIUS, SD-WAN, SASE, IdP, HCM, SIEM, PAM, CLM, MDM). The program doctrine: multiple compliant paths exist before the agency chooses; exactly one exists after — the selected path becomes mandatory once chosen, because split implementations of a truth plane recreate the fragmented-truth problem the series exists to end. If a reviewer or leader reads the necessity table as vendor lock-in, this is the standing correction.</a:t>
             </a:r>
           </a:p>
         </p:txBody>
@@ -3102,7 +3126,7 @@
                 <a:ea typeface="Calibri" pitchFamily="34" charset="-122"/>
                 <a:cs typeface="Calibri" pitchFamily="34" charset="-120"/>
               </a:rPr>
-              <a:t>NIST SP 800-53 Rev 5  ·  FedRAMP 20x Consolidated Rules (June 25, 2026)  ·  Mandatory January 1, 2027  ·  Date Code 2026-07-07 11:59 ET</a:t>
+              <a:t>NIST SP 800-53 Rev 5  ·  FedRAMP 20x Consolidated Rules (June 25, 2026)  ·  Mandatory January 1, 2027  ·  Date Code 2026-07-07 15:28 ET</a:t>
             </a:r>
             <a:endParaRPr lang="en-US" sz="1200" dirty="0"/>
           </a:p>
@@ -3173,7 +3197,7 @@
                 <a:ea typeface="Calibri" pitchFamily="34" charset="-122"/>
                 <a:cs typeface="Calibri" pitchFamily="34" charset="-120"/>
               </a:rPr>
-              <a:t>Federal AAN — Executive Summary  ·  CSI Team Draft — Internal, Not for Public Distribution  ·  Date Code 2026-07-07 11:59 ET</a:t>
+              <a:t>Federal AAN — Executive Summary  ·  CSI Team Draft — Internal, Not for Public Distribution  ·  Date Code 2026-07-07 15:28 ET</a:t>
             </a:r>
             <a:endParaRPr lang="en-US" sz="900" dirty="0"/>
           </a:p>
@@ -3385,7 +3409,7 @@
                 <a:ea typeface="Calibri" pitchFamily="34" charset="-122"/>
                 <a:cs typeface="Calibri" pitchFamily="34" charset="-120"/>
               </a:rPr>
-              <a:t>Federal AAN — Executive Summary  ·  CSI Team Draft — Internal, Not for Public Distribution  ·  Date Code 2026-07-07 11:59 ET</a:t>
+              <a:t>Federal AAN — Executive Summary  ·  CSI Team Draft — Internal, Not for Public Distribution  ·  Date Code 2026-07-07 15:28 ET</a:t>
             </a:r>
             <a:endParaRPr lang="en-US" sz="900" dirty="0"/>
           </a:p>
@@ -3597,7 +3621,7 @@
                 <a:ea typeface="Calibri" pitchFamily="34" charset="-122"/>
                 <a:cs typeface="Calibri" pitchFamily="34" charset="-120"/>
               </a:rPr>
-              <a:t>Federal AAN — Executive Summary  ·  CSI Team Draft — Internal, Not for Public Distribution  ·  Date Code 2026-07-07 11:59 ET</a:t>
+              <a:t>Federal AAN — Executive Summary  ·  CSI Team Draft — Internal, Not for Public Distribution  ·  Date Code 2026-07-07 15:28 ET</a:t>
             </a:r>
             <a:endParaRPr lang="en-US" sz="900" dirty="0"/>
           </a:p>
@@ -3848,7 +3872,7 @@
                 <a:ea typeface="Calibri" pitchFamily="34" charset="-122"/>
                 <a:cs typeface="Calibri" pitchFamily="34" charset="-120"/>
               </a:rPr>
-              <a:t>Federal AAN — Executive Summary  ·  CSI Team Draft — Internal, Not for Public Distribution  ·  Date Code 2026-07-07 11:59 ET</a:t>
+              <a:t>Federal AAN — Executive Summary  ·  CSI Team Draft — Internal, Not for Public Distribution  ·  Date Code 2026-07-07 15:28 ET</a:t>
             </a:r>
             <a:endParaRPr lang="en-US" sz="900" dirty="0"/>
           </a:p>
@@ -4060,7 +4084,7 @@
                 <a:ea typeface="Calibri" pitchFamily="34" charset="-122"/>
                 <a:cs typeface="Calibri" pitchFamily="34" charset="-120"/>
               </a:rPr>
-              <a:t>Federal AAN — Executive Summary  ·  CSI Team Draft — Internal, Not for Public Distribution  ·  Date Code 2026-07-07 11:59 ET</a:t>
+              <a:t>Federal AAN — Executive Summary  ·  CSI Team Draft — Internal, Not for Public Distribution  ·  Date Code 2026-07-07 15:28 ET</a:t>
             </a:r>
             <a:endParaRPr lang="en-US" sz="900" dirty="0"/>
           </a:p>
@@ -4272,7 +4296,7 @@
                 <a:ea typeface="Calibri" pitchFamily="34" charset="-122"/>
                 <a:cs typeface="Calibri" pitchFamily="34" charset="-120"/>
               </a:rPr>
-              <a:t>Federal AAN — Executive Summary  ·  CSI Team Draft — Internal, Not for Public Distribution  ·  Date Code 2026-07-07 11:59 ET</a:t>
+              <a:t>Federal AAN — Executive Summary  ·  CSI Team Draft — Internal, Not for Public Distribution  ·  Date Code 2026-07-07 15:28 ET</a:t>
             </a:r>
             <a:endParaRPr lang="en-US" sz="900" dirty="0"/>
           </a:p>
@@ -4484,7 +4508,7 @@
                 <a:ea typeface="Calibri" pitchFamily="34" charset="-122"/>
                 <a:cs typeface="Calibri" pitchFamily="34" charset="-120"/>
               </a:rPr>
-              <a:t>Federal AAN — Executive Summary  ·  CSI Team Draft — Internal, Not for Public Distribution  ·  Date Code 2026-07-07 11:59 ET</a:t>
+              <a:t>Federal AAN — Executive Summary  ·  CSI Team Draft — Internal, Not for Public Distribution  ·  Date Code 2026-07-07 15:28 ET</a:t>
             </a:r>
             <a:endParaRPr lang="en-US" sz="900" dirty="0"/>
           </a:p>
@@ -4696,7 +4720,7 @@
                 <a:ea typeface="Calibri" pitchFamily="34" charset="-122"/>
                 <a:cs typeface="Calibri" pitchFamily="34" charset="-120"/>
               </a:rPr>
-              <a:t>Federal AAN — Executive Summary  ·  CSI Team Draft — Internal, Not for Public Distribution  ·  Date Code 2026-07-07 11:59 ET</a:t>
+              <a:t>Federal AAN — Executive Summary  ·  CSI Team Draft — Internal, Not for Public Distribution  ·  Date Code 2026-07-07 15:28 ET</a:t>
             </a:r>
             <a:endParaRPr lang="en-US" sz="900" dirty="0"/>
           </a:p>
@@ -4908,7 +4932,7 @@
                 <a:ea typeface="Calibri" pitchFamily="34" charset="-122"/>
                 <a:cs typeface="Calibri" pitchFamily="34" charset="-120"/>
               </a:rPr>
-              <a:t>Federal AAN — Executive Summary  ·  CSI Team Draft — Internal, Not for Public Distribution  ·  Date Code 2026-07-07 11:59 ET</a:t>
+              <a:t>Federal AAN — Executive Summary  ·  CSI Team Draft — Internal, Not for Public Distribution  ·  Date Code 2026-07-07 15:28 ET</a:t>
             </a:r>
             <a:endParaRPr lang="en-US" sz="900" dirty="0"/>
           </a:p>
@@ -5120,7 +5144,7 @@
                 <a:ea typeface="Calibri" pitchFamily="34" charset="-122"/>
                 <a:cs typeface="Calibri" pitchFamily="34" charset="-120"/>
               </a:rPr>
-              <a:t>Federal AAN — Executive Summary  ·  CSI Team Draft — Internal, Not for Public Distribution  ·  Date Code 2026-07-07 11:59 ET</a:t>
+              <a:t>Federal AAN — Executive Summary  ·  CSI Team Draft — Internal, Not for Public Distribution  ·  Date Code 2026-07-07 15:28 ET</a:t>
             </a:r>
             <a:endParaRPr lang="en-US" sz="900" dirty="0"/>
           </a:p>
@@ -7089,7 +7113,7 @@
                 <a:ea typeface="Calibri" pitchFamily="34" charset="-122"/>
                 <a:cs typeface="Calibri" pitchFamily="34" charset="-120"/>
               </a:rPr>
-              <a:t>Federal AAN — Executive Summary  ·  CSI Team Draft — Internal, Not for Public Distribution  ·  Date Code 2026-07-07 11:59 ET</a:t>
+              <a:t>Federal AAN — Executive Summary  ·  CSI Team Draft — Internal, Not for Public Distribution  ·  Date Code 2026-07-07 15:28 ET</a:t>
             </a:r>
             <a:endParaRPr lang="en-US" sz="900" dirty="0"/>
           </a:p>
@@ -8140,7 +8164,7 @@
                 <a:ea typeface="Calibri" pitchFamily="34" charset="-122"/>
                 <a:cs typeface="Calibri" pitchFamily="34" charset="-120"/>
               </a:rPr>
-              <a:t>Federal AAN — Executive Summary  ·  CSI Team Draft — Internal, Not for Public Distribution  ·  Date Code 2026-07-07 11:59 ET</a:t>
+              <a:t>Federal AAN — Executive Summary  ·  CSI Team Draft — Internal, Not for Public Distribution  ·  Date Code 2026-07-07 15:28 ET</a:t>
             </a:r>
             <a:endParaRPr lang="en-US" sz="900" dirty="0"/>
           </a:p>
@@ -8352,7 +8376,7 @@
                 <a:ea typeface="Calibri" pitchFamily="34" charset="-122"/>
                 <a:cs typeface="Calibri" pitchFamily="34" charset="-120"/>
               </a:rPr>
-              <a:t>Federal AAN — Executive Summary  ·  CSI Team Draft — Internal, Not for Public Distribution  ·  Date Code 2026-07-07 11:59 ET</a:t>
+              <a:t>Federal AAN — Executive Summary  ·  CSI Team Draft — Internal, Not for Public Distribution  ·  Date Code 2026-07-07 15:28 ET</a:t>
             </a:r>
             <a:endParaRPr lang="en-US" sz="900" dirty="0"/>
           </a:p>
@@ -9756,7 +9780,7 @@
                 </a:solidFill>
                 <a:latin typeface="Calibri"/>
               </a:rPr>
-              <a:t>Federal AAN — Executive Summary  ·  CSI Team Draft — Internal, Not for Public Distribution  ·  Date Code 2026-07-07 11:59 ET</a:t>
+              <a:t>Federal AAN — Executive Summary  ·  CSI Team Draft — Internal, Not for Public Distribution  ·  Date Code 2026-07-07 15:28 ET</a:t>
             </a:r>
           </a:p>
         </p:txBody>
@@ -9860,7 +9884,7 @@
                 <a:ea typeface="Calibri" pitchFamily="34" charset="-122"/>
                 <a:cs typeface="Calibri" pitchFamily="34" charset="-120"/>
               </a:rPr>
-              <a:t>Federal AAN — Executive Summary  ·  CSI Team Draft — Internal, Not for Public Distribution  ·  Date Code 2026-07-07 11:59 ET</a:t>
+              <a:t>Federal AAN — Executive Summary  ·  CSI Team Draft — Internal, Not for Public Distribution  ·  Date Code 2026-07-07 15:28 ET</a:t>
             </a:r>
             <a:endParaRPr lang="en-US" sz="900" dirty="0"/>
           </a:p>
@@ -10072,7 +10096,7 @@
                 <a:ea typeface="Calibri" pitchFamily="34" charset="-122"/>
                 <a:cs typeface="Calibri" pitchFamily="34" charset="-120"/>
               </a:rPr>
-              <a:t>Federal AAN — Executive Summary  ·  CSI Team Draft — Internal, Not for Public Distribution  ·  Date Code 2026-07-07 11:59 ET</a:t>
+              <a:t>Federal AAN — Executive Summary  ·  CSI Team Draft — Internal, Not for Public Distribution  ·  Date Code 2026-07-07 15:28 ET</a:t>
             </a:r>
             <a:endParaRPr lang="en-US" sz="900" dirty="0"/>
           </a:p>
@@ -10284,7 +10308,7 @@
                 <a:ea typeface="Calibri" pitchFamily="34" charset="-122"/>
                 <a:cs typeface="Calibri" pitchFamily="34" charset="-120"/>
               </a:rPr>
-              <a:t>Federal AAN — Executive Summary  ·  CSI Team Draft — Internal, Not for Public Distribution  ·  Date Code 2026-07-07 11:59 ET</a:t>
+              <a:t>Federal AAN — Executive Summary  ·  CSI Team Draft — Internal, Not for Public Distribution  ·  Date Code 2026-07-07 15:28 ET</a:t>
             </a:r>
             <a:endParaRPr lang="en-US" sz="900" dirty="0"/>
           </a:p>
@@ -10549,7 +10573,7 @@
                 <a:ea typeface="Calibri" pitchFamily="34" charset="-122"/>
                 <a:cs typeface="Calibri" pitchFamily="34" charset="-120"/>
               </a:rPr>
-              <a:t>Federal AAN — Executive Summary  ·  CSI Team Draft — Internal, Not for Public Distribution  ·  Date Code 2026-07-07 11:59 ET</a:t>
+              <a:t>Federal AAN — Executive Summary  ·  CSI Team Draft — Internal, Not for Public Distribution  ·  Date Code 2026-07-07 15:28 ET</a:t>
             </a:r>
             <a:endParaRPr lang="en-US" sz="900" dirty="0"/>
           </a:p>
@@ -10761,7 +10785,7 @@
                 <a:ea typeface="Calibri" pitchFamily="34" charset="-122"/>
                 <a:cs typeface="Calibri" pitchFamily="34" charset="-120"/>
               </a:rPr>
-              <a:t>Federal AAN — Executive Summary  ·  CSI Team Draft — Internal, Not for Public Distribution  ·  Date Code 2026-07-07 11:59 ET</a:t>
+              <a:t>Federal AAN — Executive Summary  ·  CSI Team Draft — Internal, Not for Public Distribution  ·  Date Code 2026-07-07 15:28 ET</a:t>
             </a:r>
             <a:endParaRPr lang="en-US" sz="900" dirty="0"/>
           </a:p>
@@ -10973,7 +10997,7 @@
                 <a:ea typeface="Calibri" pitchFamily="34" charset="-122"/>
                 <a:cs typeface="Calibri" pitchFamily="34" charset="-120"/>
               </a:rPr>
-              <a:t>Federal AAN — Executive Summary  ·  CSI Team Draft — Internal, Not for Public Distribution  ·  Date Code 2026-07-07 11:59 ET</a:t>
+              <a:t>Federal AAN — Executive Summary  ·  CSI Team Draft — Internal, Not for Public Distribution  ·  Date Code 2026-07-07 15:28 ET</a:t>
             </a:r>
             <a:endParaRPr lang="en-US" sz="900" dirty="0"/>
           </a:p>
@@ -11185,7 +11209,7 @@
                 <a:ea typeface="Calibri" pitchFamily="34" charset="-122"/>
                 <a:cs typeface="Calibri" pitchFamily="34" charset="-120"/>
               </a:rPr>
-              <a:t>Federal AAN — Executive Summary  ·  CSI Team Draft — Internal, Not for Public Distribution  ·  Date Code 2026-07-07 11:59 ET</a:t>
+              <a:t>Federal AAN — Executive Summary  ·  CSI Team Draft — Internal, Not for Public Distribution  ·  Date Code 2026-07-07 15:28 ET</a:t>
             </a:r>
             <a:endParaRPr lang="en-US" sz="900" dirty="0"/>
           </a:p>

</xml_diff>